<commit_message>
Audit and embed accepted presentation media
Co-authored-by: Cursor <cursoragent@cursor.com>
</commit_message>
<xml_diff>
--- a/production/slides/01-u2-ch1-renewable-nonrenewable-slides.pptx
+++ b/production/slides/01-u2-ch1-renewable-nonrenewable-slides.pptx
@@ -8,6 +8,7 @@
     <p:sldId id="256" r:id="rId7"/>
     <p:sldId id="257" r:id="rId8"/>
     <p:sldId id="258" r:id="rId9"/>
+    <p:sldId id="276" r:id="rId27"/>
     <p:sldId id="259" r:id="rId10"/>
     <p:sldId id="260" r:id="rId11"/>
     <p:sldId id="261" r:id="rId12"/>
@@ -6511,6 +6512,369 @@
                 <a:latin typeface="Arial"/>
               </a:rPr>
               <a:t>C. Abundant does NOT mean renewable.</a:t>
+            </a:r>
+          </a:p>
+        </p:txBody>
+      </p:sp>
+    </p:spTree>
+  </p:cSld>
+  <p:clrMapOvr>
+    <a:masterClrMapping/>
+  </p:clrMapOvr>
+</p:sld>
+</file>
+
+<file path=ppt/slides/slide21.xml><?xml version="1.0" encoding="utf-8"?>
+<p:sld xmlns:a="http://schemas.openxmlformats.org/drawingml/2006/main" xmlns:r="http://schemas.openxmlformats.org/officeDocument/2006/relationships" xmlns:p="http://schemas.openxmlformats.org/presentationml/2006/main">
+  <p:cSld>
+    <p:spTree>
+      <p:nvGrpSpPr>
+        <p:cNvPr id="1" name=""/>
+        <p:cNvGrpSpPr/>
+        <p:nvPr/>
+      </p:nvGrpSpPr>
+      <p:grpSpPr/>
+      <p:sp>
+        <p:nvSpPr>
+          <p:cNvPr id="2" name="Rectangle 1"/>
+          <p:cNvSpPr/>
+          <p:nvPr/>
+        </p:nvSpPr>
+        <p:spPr>
+          <a:xfrm>
+            <a:off x="0" y="0"/>
+            <a:ext cx="12191695" cy="6858000"/>
+          </a:xfrm>
+          <a:prstGeom prst="rect">
+            <a:avLst/>
+          </a:prstGeom>
+          <a:solidFill>
+            <a:srgbClr val="FAFAF8"/>
+          </a:solidFill>
+          <a:ln>
+            <a:noFill/>
+          </a:ln>
+          <a:effectLst/>
+        </p:spPr>
+        <p:style>
+          <a:lnRef idx="1">
+            <a:schemeClr val="accent1"/>
+          </a:lnRef>
+          <a:fillRef idx="3">
+            <a:schemeClr val="accent1"/>
+          </a:fillRef>
+          <a:effectRef idx="2">
+            <a:schemeClr val="accent1"/>
+          </a:effectRef>
+          <a:fontRef idx="minor">
+            <a:schemeClr val="lt1"/>
+          </a:fontRef>
+        </p:style>
+        <p:txBody>
+          <a:bodyPr rtlCol="0" anchor="ctr"/>
+          <a:lstStyle/>
+          <a:p>
+            <a:pPr algn="ctr"/>
+          </a:p>
+        </p:txBody>
+      </p:sp>
+      <p:sp>
+        <p:nvSpPr>
+          <p:cNvPr id="3" name="Rectangle 2"/>
+          <p:cNvSpPr/>
+          <p:nvPr/>
+        </p:nvSpPr>
+        <p:spPr>
+          <a:xfrm>
+            <a:off x="0" y="0"/>
+            <a:ext cx="12191695" cy="1417320"/>
+          </a:xfrm>
+          <a:prstGeom prst="rect">
+            <a:avLst/>
+          </a:prstGeom>
+          <a:solidFill>
+            <a:srgbClr val="2F3C7E"/>
+          </a:solidFill>
+          <a:ln>
+            <a:noFill/>
+          </a:ln>
+          <a:effectLst/>
+        </p:spPr>
+        <p:style>
+          <a:lnRef idx="1">
+            <a:schemeClr val="accent1"/>
+          </a:lnRef>
+          <a:fillRef idx="3">
+            <a:schemeClr val="accent1"/>
+          </a:fillRef>
+          <a:effectRef idx="2">
+            <a:schemeClr val="accent1"/>
+          </a:effectRef>
+          <a:fontRef idx="minor">
+            <a:schemeClr val="lt1"/>
+          </a:fontRef>
+        </p:style>
+        <p:txBody>
+          <a:bodyPr rtlCol="0" anchor="ctr"/>
+          <a:lstStyle/>
+          <a:p>
+            <a:pPr algn="ctr"/>
+          </a:p>
+        </p:txBody>
+      </p:sp>
+      <p:sp>
+        <p:nvSpPr>
+          <p:cNvPr id="4" name="TextBox 3"/>
+          <p:cNvSpPr txBox="1"/>
+          <p:nvPr/>
+        </p:nvSpPr>
+        <p:spPr>
+          <a:xfrm>
+            <a:off x="457200" y="109728"/>
+            <a:ext cx="10424160" cy="868680"/>
+          </a:xfrm>
+          <a:prstGeom prst="rect">
+            <a:avLst/>
+          </a:prstGeom>
+          <a:noFill/>
+        </p:spPr>
+        <p:txBody>
+          <a:bodyPr wrap="square" anchor="ctr">
+            <a:spAutoFit/>
+          </a:bodyPr>
+          <a:lstStyle/>
+          <a:p>
+            <a:pPr algn="l">
+              <a:spcAft>
+                <a:spcPts val="400"/>
+              </a:spcAft>
+            </a:pPr>
+            <a:r>
+              <a:rPr sz="3200" b="1">
+                <a:solidFill>
+                  <a:srgbClr val="FFFFFF"/>
+                </a:solidFill>
+                <a:latin typeface="Arial"/>
+              </a:rPr>
+              <a:t>Where Does Our Energy Come From?</a:t>
+            </a:r>
+          </a:p>
+        </p:txBody>
+      </p:sp>
+      <p:sp>
+        <p:nvSpPr>
+          <p:cNvPr id="5" name="TextBox 4"/>
+          <p:cNvSpPr txBox="1"/>
+          <p:nvPr/>
+        </p:nvSpPr>
+        <p:spPr>
+          <a:xfrm>
+            <a:off x="457200" y="1024128"/>
+            <a:ext cx="10424160" cy="329184"/>
+          </a:xfrm>
+          <a:prstGeom prst="rect">
+            <a:avLst/>
+          </a:prstGeom>
+          <a:noFill/>
+        </p:spPr>
+        <p:txBody>
+          <a:bodyPr wrap="square" anchor="ctr">
+            <a:spAutoFit/>
+          </a:bodyPr>
+          <a:lstStyle/>
+          <a:p>
+            <a:pPr algn="l">
+              <a:spcAft>
+                <a:spcPts val="400"/>
+              </a:spcAft>
+            </a:pPr>
+            <a:r>
+              <a:rPr sz="1500" b="0">
+                <a:solidFill>
+                  <a:srgbClr val="C9D2E8"/>
+                </a:solidFill>
+                <a:latin typeface="Arial"/>
+              </a:rPr>
+              <a:t>Media placeholder · optional video · pending generation</a:t>
+            </a:r>
+          </a:p>
+        </p:txBody>
+      </p:sp>
+      <p:sp>
+        <p:nvSpPr>
+          <p:cNvPr id="6" name="TextBox 5"/>
+          <p:cNvSpPr txBox="1"/>
+          <p:nvPr/>
+        </p:nvSpPr>
+        <p:spPr>
+          <a:xfrm>
+            <a:off x="10607040" y="310896"/>
+            <a:ext cx="731520" cy="365760"/>
+          </a:xfrm>
+          <a:prstGeom prst="rect">
+            <a:avLst/>
+          </a:prstGeom>
+          <a:noFill/>
+        </p:spPr>
+        <p:txBody>
+          <a:bodyPr wrap="square" anchor="ctr">
+            <a:spAutoFit/>
+          </a:bodyPr>
+          <a:lstStyle/>
+          <a:p>
+            <a:pPr algn="r">
+              <a:spcAft>
+                <a:spcPts val="400"/>
+              </a:spcAft>
+            </a:pPr>
+            <a:r>
+              <a:rPr sz="1500" b="0">
+                <a:solidFill>
+                  <a:srgbClr val="C9D2E8"/>
+                </a:solidFill>
+                <a:latin typeface="Arial"/>
+              </a:rPr>
+              <a:t>4</a:t>
+            </a:r>
+          </a:p>
+        </p:txBody>
+      </p:sp>
+      <p:sp>
+        <p:nvSpPr>
+          <p:cNvPr id="7" name="Rounded Rectangle 6"/>
+          <p:cNvSpPr/>
+          <p:nvPr/>
+        </p:nvSpPr>
+        <p:spPr>
+          <a:xfrm>
+            <a:off x="10972800" y="256032"/>
+            <a:ext cx="1051560" cy="420624"/>
+          </a:xfrm>
+          <a:prstGeom prst="roundRect">
+            <a:avLst/>
+          </a:prstGeom>
+          <a:solidFill>
+            <a:srgbClr val="2F3C7E"/>
+          </a:solidFill>
+          <a:ln>
+            <a:noFill/>
+          </a:ln>
+          <a:effectLst/>
+        </p:spPr>
+        <p:style>
+          <a:lnRef idx="1">
+            <a:schemeClr val="accent1"/>
+          </a:lnRef>
+          <a:fillRef idx="3">
+            <a:schemeClr val="accent1"/>
+          </a:fillRef>
+          <a:effectRef idx="2">
+            <a:schemeClr val="accent1"/>
+          </a:effectRef>
+          <a:fontRef idx="minor">
+            <a:schemeClr val="lt1"/>
+          </a:fontRef>
+        </p:style>
+        <p:txBody>
+          <a:bodyPr rtlCol="0" anchor="ctr" wrap="none"/>
+          <a:lstStyle/>
+          <a:p>
+            <a:pPr algn="ctr"/>
+            <a:r>
+              <a:rPr sz="1100" b="1">
+                <a:solidFill>
+                  <a:srgbClr val="FFFFFF"/>
+                </a:solidFill>
+                <a:latin typeface="Arial"/>
+              </a:rPr>
+              <a:t>PLACEHOLDER</a:t>
+            </a:r>
+          </a:p>
+        </p:txBody>
+      </p:sp>
+      <p:sp>
+        <p:nvSpPr>
+          <p:cNvPr id="8" name="TextBox 7"/>
+          <p:cNvSpPr txBox="1"/>
+          <p:nvPr/>
+        </p:nvSpPr>
+        <p:spPr>
+          <a:xfrm>
+            <a:off x="822960" y="1700000"/>
+            <a:ext cx="10515600" cy="4400000"/>
+          </a:xfrm>
+          <a:prstGeom prst="rect">
+            <a:avLst/>
+          </a:prstGeom>
+          <a:noFill/>
+        </p:spPr>
+        <p:txBody>
+          <a:bodyPr wrap="square">
+            <a:spAutoFit/>
+          </a:bodyPr>
+          <a:lstStyle/>
+          <a:p>
+            <a:pPr>
+              <a:spcAft>
+                <a:spcPts val="1000"/>
+              </a:spcAft>
+            </a:pPr>
+            <a:r>
+              <a:rPr sz="2000" b="1">
+                <a:solidFill>
+                  <a:srgbClr val="1F1F1F"/>
+                </a:solidFill>
+                <a:latin typeface="Arial"/>
+              </a:rPr>
+              <a:t>Intended: ~90-second Unit 2 launch video (Week 5 Monday).</a:t>
+            </a:r>
+          </a:p>
+          <a:p>
+            <a:pPr>
+              <a:spcAft>
+                <a:spcPts val="1000"/>
+              </a:spcAft>
+            </a:pPr>
+            <a:r>
+              <a:rPr sz="2000" b="0">
+                <a:solidFill>
+                  <a:srgbClr val="1F1F1F"/>
+                </a:solidFill>
+                <a:latin typeface="Arial"/>
+              </a:rPr>
+              <a:t>Script ready: production/media/scripts/unit-02/01-where-does-our-energy-come-from-final-script.md</a:t>
+            </a:r>
+          </a:p>
+          <a:p>
+            <a:pPr>
+              <a:spcAft>
+                <a:spcPts val="1000"/>
+              </a:spcAft>
+            </a:pPr>
+            <a:r>
+              <a:rPr sz="2000" b="0">
+                <a:solidFill>
+                  <a:srgbClr val="1F1F1F"/>
+                </a:solidFill>
+                <a:latin typeface="Arial"/>
+              </a:rPr>
+              <a:t>Covers: natural resources → renewable vs nonrenewable → benefits/limitations.</a:t>
+            </a:r>
+          </a:p>
+          <a:p>
+            <a:pPr>
+              <a:spcAft>
+                <a:spcPts val="1000"/>
+              </a:spcAft>
+            </a:pPr>
+            <a:r>
+              <a:rPr sz="2000" b="0">
+                <a:solidFill>
+                  <a:srgbClr val="1F1F1F"/>
+                </a:solidFill>
+                <a:latin typeface="Arial"/>
+              </a:rPr>
+              <a:t>This slide is a drop-in slot — the deck teaches fully without the video.</a:t>
             </a:r>
           </a:p>
         </p:txBody>

</xml_diff>

<commit_message>
Fix science regression and rebuild pending-video placeholders as premium WATCH slides
Co-authored-by: Cursor <cursoragent@cursor.com>
</commit_message>
<xml_diff>
--- a/production/slides/01-u2-ch1-renewable-nonrenewable-slides.pptx
+++ b/production/slides/01-u2-ch1-renewable-nonrenewable-slides.pptx
@@ -540,6 +540,91 @@
           <a:p>
             <a:r>
               <a:t>Approved rebuilt visual — production/infographics/unit2-renewable-nonrenewable-resources.png. Locked Grade 4 vocabulary only.</a:t>
+            </a:r>
+          </a:p>
+        </p:txBody>
+      </p:sp>
+      <p:sp>
+        <p:nvSpPr>
+          <p:cNvPr id="4" name="Slide Number Placeholder 3"/>
+          <p:cNvSpPr>
+            <a:spLocks noGrp="1"/>
+          </p:cNvSpPr>
+          <p:nvPr>
+            <p:ph type="sldNum" idx="5" sz="quarter"/>
+          </p:nvPr>
+        </p:nvSpPr>
+        <p:spPr/>
+      </p:sp>
+    </p:spTree>
+  </p:cSld>
+  <p:clrMapOvr>
+    <a:masterClrMapping/>
+  </p:clrMapOvr>
+</p:notes>
+</file>
+
+<file path=ppt/notesSlides/notesSlide2.xml><?xml version="1.0" encoding="utf-8"?>
+<p:notes xmlns:a="http://schemas.openxmlformats.org/drawingml/2006/main" xmlns:p="http://schemas.openxmlformats.org/presentationml/2006/main" xmlns:r="http://schemas.openxmlformats.org/officeDocument/2006/relationships">
+  <p:cSld>
+    <p:spTree>
+      <p:nvGrpSpPr>
+        <p:cNvPr id="1" name=""/>
+        <p:cNvGrpSpPr/>
+        <p:nvPr/>
+      </p:nvGrpSpPr>
+      <p:grpSpPr>
+        <a:xfrm>
+          <a:off x="0" y="0"/>
+          <a:ext cx="0" cy="0"/>
+          <a:chOff x="0" y="0"/>
+          <a:chExt cx="0" cy="0"/>
+        </a:xfrm>
+      </p:grpSpPr>
+      <p:sp>
+        <p:nvSpPr>
+          <p:cNvPr id="2" name="Slide Image Placeholder 1"/>
+          <p:cNvSpPr>
+            <a:spLocks noGrp="1"/>
+          </p:cNvSpPr>
+          <p:nvPr>
+            <p:ph type="sldImg" idx="2"/>
+          </p:nvPr>
+        </p:nvSpPr>
+        <p:spPr/>
+      </p:sp>
+      <p:sp>
+        <p:nvSpPr>
+          <p:cNvPr id="3" name="Notes Placeholder 2"/>
+          <p:cNvSpPr>
+            <a:spLocks noGrp="1"/>
+          </p:cNvSpPr>
+          <p:nvPr>
+            <p:ph type="body" idx="3" sz="quarter"/>
+          </p:nvPr>
+        </p:nvSpPr>
+        <p:spPr/>
+        <p:txBody>
+          <a:bodyPr/>
+          <a:lstStyle/>
+          <a:p>
+            <a:r>
+              <a:t>Intended: ~90-second Unit 2 launch video (Week 5 Monday).</a:t>
+            </a:r>
+          </a:p>
+          <a:p>
+            <a:r>
+              <a:t>Script ready: production/media/scripts/unit-02/01-where-does-our-energy-come-from-final-script.md</a:t>
+            </a:r>
+          </a:p>
+          <a:p>
+            <a:r>
+              <a:t>Covers: natural resources → renewable vs nonrenewable → benefits/limitations.</a:t>
+            </a:r>
+          </a:p>
+          <a:p>
+            <a:r>
+              <a:t>This slide is a drop-in slot — the deck teaches fully without the video.</a:t>
             </a:r>
           </a:p>
         </p:txBody>
@@ -8010,7 +8095,7 @@
                 </a:solidFill>
                 <a:latin typeface="Arial"/>
               </a:rPr>
-              <a:t>Media placeholder · optional video · pending generation</a:t>
+              <a:t>Optional video · Week 5 Monday</a:t>
             </a:r>
           </a:p>
         </p:txBody>
@@ -8091,7 +8176,7 @@
           </a:fontRef>
         </p:style>
         <p:txBody>
-          <a:bodyPr rtlCol="0" anchor="ctr" wrap="none"/>
+          <a:bodyPr rtlCol="0" anchor="ctr" wrap="square"/>
           <a:lstStyle/>
           <a:p>
             <a:pPr algn="ctr"/>
@@ -8102,7 +8187,7 @@
                 </a:solidFill>
                 <a:latin typeface="Arial"/>
               </a:rPr>
-              <a:t>PLACEHOLDER</a:t>
+              <a:t>WATCH</a:t>
             </a:r>
           </a:p>
         </p:txBody>
@@ -8115,8 +8200,8 @@
         </p:nvSpPr>
         <p:spPr>
           <a:xfrm>
-            <a:off x="822960" y="1700000"/>
-            <a:ext cx="10515600" cy="4400000"/>
+            <a:off x="457200" y="6500000"/>
+            <a:ext cx="11277295" cy="300000"/>
           </a:xfrm>
           <a:prstGeom prst="rect">
             <a:avLst/>
@@ -8129,68 +8214,148 @@
           </a:bodyPr>
           <a:lstStyle/>
           <a:p>
-            <a:pPr>
-              <a:spcAft>
-                <a:spcPts val="1000"/>
-              </a:spcAft>
-            </a:pPr>
-            <a:r>
-              <a:rPr sz="2000" b="1">
-                <a:solidFill>
-                  <a:srgbClr val="1F1F1F"/>
-                </a:solidFill>
-                <a:latin typeface="Arial"/>
-              </a:rPr>
-              <a:t>Intended: ~90-second Unit 2 launch video (Week 5 Monday).</a:t>
-            </a:r>
-          </a:p>
-          <a:p>
-            <a:pPr>
-              <a:spcAft>
-                <a:spcPts val="1000"/>
-              </a:spcAft>
-            </a:pPr>
-            <a:r>
-              <a:rPr sz="2000" b="0">
-                <a:solidFill>
-                  <a:srgbClr val="1F1F1F"/>
-                </a:solidFill>
-                <a:latin typeface="Arial"/>
-              </a:rPr>
-              <a:t>Script ready: production/media/scripts/unit-02/01-where-does-our-energy-come-from-final-script.md</a:t>
-            </a:r>
-          </a:p>
-          <a:p>
-            <a:pPr>
-              <a:spcAft>
-                <a:spcPts val="1000"/>
-              </a:spcAft>
-            </a:pPr>
-            <a:r>
-              <a:rPr sz="2000" b="0">
-                <a:solidFill>
-                  <a:srgbClr val="1F1F1F"/>
-                </a:solidFill>
-                <a:latin typeface="Arial"/>
-              </a:rPr>
-              <a:t>Covers: natural resources → renewable vs nonrenewable → benefits/limitations.</a:t>
-            </a:r>
-          </a:p>
-          <a:p>
-            <a:pPr>
-              <a:spcAft>
-                <a:spcPts val="1000"/>
-              </a:spcAft>
-            </a:pPr>
-            <a:r>
-              <a:rPr sz="2000" b="0">
-                <a:solidFill>
-                  <a:srgbClr val="1F1F1F"/>
-                </a:solidFill>
-                <a:latin typeface="Arial"/>
-              </a:rPr>
-              <a:t>This slide is a drop-in slot — the deck teaches fully without the video.</a:t>
-            </a:r>
+            <a:pPr algn="ctr"/>
+            <a:r>
+              <a:rPr sz="1800" b="1">
+                <a:solidFill>
+                  <a:srgbClr val="2F3C7E"/>
+                </a:solidFill>
+                <a:latin typeface="Arial"/>
+              </a:rPr>
+              <a:t>THINK: Where do the resources we use every day come from?</a:t>
+            </a:r>
+          </a:p>
+        </p:txBody>
+      </p:sp>
+      <p:sp>
+        <p:nvSpPr>
+          <p:cNvPr id="9" name="Rounded Rectangle 8"/>
+          <p:cNvSpPr/>
+          <p:nvPr/>
+        </p:nvSpPr>
+        <p:spPr>
+          <a:xfrm>
+            <a:off x="1895847" y="1720000"/>
+            <a:ext cx="8400000" cy="4725000"/>
+          </a:xfrm>
+          <a:prstGeom prst="roundRect">
+            <a:avLst/>
+          </a:prstGeom>
+          <a:solidFill>
+            <a:srgbClr val="E8ECF6"/>
+          </a:solidFill>
+          <a:ln>
+            <a:noFill/>
+          </a:ln>
+          <a:effectLst/>
+        </p:spPr>
+        <p:style>
+          <a:lnRef idx="1">
+            <a:schemeClr val="accent1"/>
+          </a:lnRef>
+          <a:fillRef idx="3">
+            <a:schemeClr val="accent1"/>
+          </a:fillRef>
+          <a:effectRef idx="2">
+            <a:schemeClr val="accent1"/>
+          </a:effectRef>
+          <a:fontRef idx="minor">
+            <a:schemeClr val="lt1"/>
+          </a:fontRef>
+        </p:style>
+        <p:txBody>
+          <a:bodyPr rtlCol="0" anchor="ctr"/>
+          <a:lstStyle/>
+          <a:p>
+            <a:pPr algn="ctr"/>
+          </a:p>
+        </p:txBody>
+      </p:sp>
+      <p:sp>
+        <p:nvSpPr>
+          <p:cNvPr id="10" name="Oval 9"/>
+          <p:cNvSpPr/>
+          <p:nvPr/>
+        </p:nvSpPr>
+        <p:spPr>
+          <a:xfrm>
+            <a:off x="5410047" y="3396700"/>
+            <a:ext cx="1371600" cy="1371600"/>
+          </a:xfrm>
+          <a:prstGeom prst="ellipse">
+            <a:avLst/>
+          </a:prstGeom>
+          <a:solidFill>
+            <a:srgbClr val="2F3C7E"/>
+          </a:solidFill>
+          <a:ln>
+            <a:noFill/>
+          </a:ln>
+          <a:effectLst/>
+        </p:spPr>
+        <p:style>
+          <a:lnRef idx="1">
+            <a:schemeClr val="accent1"/>
+          </a:lnRef>
+          <a:fillRef idx="3">
+            <a:schemeClr val="accent1"/>
+          </a:fillRef>
+          <a:effectRef idx="2">
+            <a:schemeClr val="accent1"/>
+          </a:effectRef>
+          <a:fontRef idx="minor">
+            <a:schemeClr val="lt1"/>
+          </a:fontRef>
+        </p:style>
+        <p:txBody>
+          <a:bodyPr rtlCol="0" anchor="ctr"/>
+          <a:lstStyle/>
+          <a:p>
+            <a:pPr algn="ctr"/>
+          </a:p>
+        </p:txBody>
+      </p:sp>
+      <p:sp>
+        <p:nvSpPr>
+          <p:cNvPr id="11" name="Isosceles Triangle 10"/>
+          <p:cNvSpPr/>
+          <p:nvPr/>
+        </p:nvSpPr>
+        <p:spPr>
+          <a:xfrm rot="5400000">
+            <a:off x="5821527" y="3808180"/>
+            <a:ext cx="548640" cy="548640"/>
+          </a:xfrm>
+          <a:prstGeom prst="triangle">
+            <a:avLst/>
+          </a:prstGeom>
+          <a:solidFill>
+            <a:srgbClr val="FFFFFF"/>
+          </a:solidFill>
+          <a:ln>
+            <a:noFill/>
+          </a:ln>
+          <a:effectLst/>
+        </p:spPr>
+        <p:style>
+          <a:lnRef idx="1">
+            <a:schemeClr val="accent1"/>
+          </a:lnRef>
+          <a:fillRef idx="3">
+            <a:schemeClr val="accent1"/>
+          </a:fillRef>
+          <a:effectRef idx="2">
+            <a:schemeClr val="accent1"/>
+          </a:effectRef>
+          <a:fontRef idx="minor">
+            <a:schemeClr val="lt1"/>
+          </a:fontRef>
+        </p:style>
+        <p:txBody>
+          <a:bodyPr rtlCol="0" anchor="ctr"/>
+          <a:lstStyle/>
+          <a:p>
+            <a:pPr algn="ctr"/>
           </a:p>
         </p:txBody>
       </p:sp>

</xml_diff>